<commit_message>
Revisão dos slides e do relatório com as medições do Linux
Depois do merge conferi os slides e o relatório contra a main:

- o make bench rodado no Linux gravou os tempos com vírgula decimal
  (locale pt_BR no awk), o que quebrava as colunas do CSV; corrigi o
  medicoes.csv (mesmos dados) e o medir.sh agora força LC_ALL=C
- gráficos regenerados com os dados do Linux; os rótulos finais do
  gráfico de aceleração não ficam mais um em cima do outro
- slides: nomes na capa, tabela de desempenho e ambiente do slide 11
  com os números do Ryzen/Linux, nota do slide 11 atualizada
- relatório: tabelas 9.3 e 9.4 geradas do CSV novo, análise e conclusão
  ajustadas (8 núcleos físicos, S(8) = 3,00), caso A7 sem as matrizes que
  saíram do repositório e comandos do Apêndice A para Linux

Co-Authored-By: Claude Opus 5.5 (1M context) <noreply@anthropic.com>
</commit_message>
<xml_diff>
--- a/slides/apresentacao.pptx
+++ b/slides/apresentacao.pptx
@@ -732,7 +732,7 @@
           <a:p>
             <a:r>
               <a:rPr lang="en-US" dirty="0"/>
-              <a:t>1 min. Com 1 thread o paralelo é mais lento (S = 0,86): criação da thread e alocação dos rótulos e do union-find. Com 4 threads S = 2,55; de 4 para 8 quase não melhora porque a máquina tem 4 núcleos físicos. Medido no Windows; refazer no Linux para a entrega.</a:t>
+              <a:t>1 min. Com 1 thread o paralelo é mais lento (S = 0,82): criação da thread e alocação dos rótulos e do union-find. Com 8 threads S = 3,00, mas a eficiência cai de 0,73 (p = 2) para 0,38 (p = 8) porque a alocação dos rótulos e a consolidação continuam sequenciais (Amdahl).</a:t>
             </a:r>
             <a:endParaRPr lang="en-US" dirty="0"/>
           </a:p>
@@ -2489,7 +2489,7 @@
         <p:spPr>
           <a:xfrm>
             <a:off x="640080" y="3246120"/>
-            <a:ext cx="5120640" cy="1005840"/>
+            <a:ext cx="5120640" cy="1371600"/>
           </a:xfrm>
           <a:prstGeom prst="rect">
             <a:avLst/>
@@ -2542,12 +2542,12 @@
               <a:buNone/>
             </a:pPr>
             <a:r>
-              <a:rPr lang="en-US" sz="1800" b="1" dirty="0">
+              <a:rPr lang="en-US" sz="1400" b="1" dirty="0">
                 <a:solidFill>
-                  <a:schemeClr val="accent2"/>
+                  <a:schemeClr val="bg1"/>
                 </a:solidFill>
               </a:rPr>
-              <a:t>[PREENCHER nomes dos integrantes]</a:t>
+              <a:t>Isadora Santos, Jhone Salvador e Nathan Schmitt</a:t>
             </a:r>
             <a:endParaRPr lang="en-US" sz="1800" dirty="0"/>
           </a:p>
@@ -6142,7 +6142,7 @@
                             <a:schemeClr val="tx1"/>
                           </a:solidFill>
                         </a:rPr>
-                        <a:t>236,30</a:t>
+                        <a:t>121,83</a:t>
                       </a:r>
                       <a:endParaRPr lang="en-US" sz="1400" dirty="0"/>
                     </a:p>
@@ -6449,7 +6449,7 @@
                             <a:schemeClr val="tx1"/>
                           </a:solidFill>
                         </a:rPr>
-                        <a:t>274,96</a:t>
+                        <a:t>148,39</a:t>
                       </a:r>
                       <a:endParaRPr lang="en-US" sz="1400" dirty="0"/>
                     </a:p>
@@ -6510,7 +6510,7 @@
                             <a:schemeClr val="tx1"/>
                           </a:solidFill>
                         </a:rPr>
-                        <a:t>0,86</a:t>
+                        <a:t>0,82</a:t>
                       </a:r>
                       <a:endParaRPr lang="en-US" sz="1400" dirty="0"/>
                     </a:p>
@@ -6571,7 +6571,7 @@
                             <a:schemeClr val="tx1"/>
                           </a:solidFill>
                         </a:rPr>
-                        <a:t>0,86</a:t>
+                        <a:t>0,82</a:t>
                       </a:r>
                       <a:endParaRPr lang="en-US" sz="1400" dirty="0"/>
                     </a:p>
@@ -6756,7 +6756,7 @@
                             <a:schemeClr val="tx1"/>
                           </a:solidFill>
                         </a:rPr>
-                        <a:t>136,88</a:t>
+                        <a:t>83,29</a:t>
                       </a:r>
                       <a:endParaRPr lang="en-US" sz="1400" dirty="0"/>
                     </a:p>
@@ -6817,7 +6817,7 @@
                             <a:schemeClr val="tx1"/>
                           </a:solidFill>
                         </a:rPr>
-                        <a:t>1,73</a:t>
+                        <a:t>1,46</a:t>
                       </a:r>
                       <a:endParaRPr lang="en-US" sz="1400" dirty="0"/>
                     </a:p>
@@ -6878,7 +6878,7 @@
                             <a:schemeClr val="tx1"/>
                           </a:solidFill>
                         </a:rPr>
-                        <a:t>0,86</a:t>
+                        <a:t>0,73</a:t>
                       </a:r>
                       <a:endParaRPr lang="en-US" sz="1400" dirty="0"/>
                     </a:p>
@@ -7063,7 +7063,7 @@
                             <a:schemeClr val="tx1"/>
                           </a:solidFill>
                         </a:rPr>
-                        <a:t>92,57</a:t>
+                        <a:t>53,72</a:t>
                       </a:r>
                       <a:endParaRPr lang="en-US" sz="1400" dirty="0"/>
                     </a:p>
@@ -7124,7 +7124,7 @@
                             <a:schemeClr val="tx1"/>
                           </a:solidFill>
                         </a:rPr>
-                        <a:t>2,55</a:t>
+                        <a:t>2,27</a:t>
                       </a:r>
                       <a:endParaRPr lang="en-US" sz="1400" dirty="0"/>
                     </a:p>
@@ -7185,7 +7185,7 @@
                             <a:schemeClr val="tx1"/>
                           </a:solidFill>
                         </a:rPr>
-                        <a:t>0,64</a:t>
+                        <a:t>0,57</a:t>
                       </a:r>
                       <a:endParaRPr lang="en-US" sz="1400" dirty="0"/>
                     </a:p>
@@ -7370,7 +7370,7 @@
                             <a:schemeClr val="tx1"/>
                           </a:solidFill>
                         </a:rPr>
-                        <a:t>84,24</a:t>
+                        <a:t>40,57</a:t>
                       </a:r>
                       <a:endParaRPr lang="en-US" sz="1400" dirty="0"/>
                     </a:p>
@@ -7431,7 +7431,7 @@
                             <a:schemeClr val="tx1"/>
                           </a:solidFill>
                         </a:rPr>
-                        <a:t>2,81</a:t>
+                        <a:t>3,00</a:t>
                       </a:r>
                       <a:endParaRPr lang="en-US" sz="1400" dirty="0"/>
                     </a:p>
@@ -7492,7 +7492,7 @@
                             <a:schemeClr val="tx1"/>
                           </a:solidFill>
                         </a:rPr>
-                        <a:t>0,35</a:t>
+                        <a:t>0,38</a:t>
                       </a:r>
                       <a:endParaRPr lang="en-US" sz="1400" dirty="0"/>
                     </a:p>
@@ -7577,7 +7577,7 @@
                   <a:schemeClr val="accent4"/>
                 </a:solidFill>
               </a:rPr>
-              <a:t>Matriz: 2000x2000, ~50% de 1s (genMatriz.py, semente 2026), 13345 objetos. Ambiente: i7-1185G7, 4 núcleos/8 threads, Windows 11, zig cc 0.16 -O2. Dados: results/medicoes.csv</a:t>
+              <a:t>Matriz 2000x2000 (~50% de 1s, semente 2026, 13345 objetos). Ryzen 7 7735HS, 8 núcleos/16 threads, Linux Mint 22.3, GCC 13.3 -O2. Dados: results/medicoes.csv</a:t>
             </a:r>
             <a:endParaRPr lang="en-US" sz="1200" dirty="0"/>
           </a:p>

</xml_diff>